<commit_message>
docs: document real data, API auth and affordability; refresh deliverables
- README: 24-source catalog, real DVF/INSEE sources, auth+quota section, affordability KPI
- update grid mapping (C2.1 auth, C2.3/C2.4 real data + quality)
- regenerate PDF report and PPTX deck with updated facts and screenshots (map + Swagger)
- embed official EFREI logos
</commit_message>
<xml_diff>
--- a/soutenance.pptx
+++ b/soutenance.pptx
@@ -5231,7 +5231,7 @@
                 </a:solidFill>
                 <a:latin typeface="Arial"/>
               </a:rPr>
-              <a:t>Prix au m² &amp; volumes de ventes</a:t>
+              <a:t>Prix au m² réel &amp; ventes (DVF 2023)</a:t>
             </a:r>
           </a:p>
         </p:txBody>
@@ -5514,7 +5514,7 @@
                 </a:solidFill>
                 <a:latin typeface="Arial"/>
               </a:rPr>
-              <a:t>Revenus &amp; socio-éco</a:t>
+              <a:t>Revenus</a:t>
             </a:r>
           </a:p>
           <a:p>
@@ -5533,7 +5533,7 @@
                 </a:solidFill>
                 <a:latin typeface="Arial"/>
               </a:rPr>
-              <a:t>Revenu médian par ménage (INSEE)</a:t>
+              <a:t>Revenu médian réel (INSEE Filosofi)</a:t>
             </a:r>
           </a:p>
         </p:txBody>
@@ -5665,7 +5665,7 @@
                 </a:solidFill>
                 <a:latin typeface="Arial"/>
               </a:rPr>
-              <a:t>Cadre de vie</a:t>
+              <a:t>Accessibilité</a:t>
             </a:r>
           </a:p>
           <a:p>
@@ -5684,7 +5684,7 @@
                 </a:solidFill>
                 <a:latin typeface="Arial"/>
               </a:rPr>
-              <a:t>Accessibilité, transports, équipements</a:t>
+              <a:t>m² achetables / an de revenu (prix ÷ revenu)</a:t>
             </a:r>
           </a:p>
         </p:txBody>
@@ -5816,7 +5816,7 @@
                 </a:solidFill>
                 <a:latin typeface="Arial"/>
               </a:rPr>
-              <a:t>Environnement</a:t>
+              <a:t>Cadre de vie &amp; env.</a:t>
             </a:r>
           </a:p>
           <a:p>
@@ -5835,7 +5835,7 @@
                 </a:solidFill>
                 <a:latin typeface="Arial"/>
               </a:rPr>
-              <a:t>Espaces verts &amp; nature en ville</a:t>
+              <a:t>Transports, équipements, espaces verts</a:t>
             </a:r>
           </a:p>
         </p:txBody>
@@ -5986,7 +5986,7 @@
                 </a:solidFill>
                 <a:latin typeface="Arial"/>
               </a:rPr>
-              <a:t>Moyenne des 5 indices /100</a:t>
+              <a:t>Moyenne des indices /100</a:t>
             </a:r>
           </a:p>
         </p:txBody>
@@ -7759,7 +7759,7 @@
                           </a:solidFill>
                           <a:latin typeface="Arial"/>
                         </a:rPr>
-                        <a:t>FastAPI documentée /docs</a:t>
+                        <a:t>FastAPI /docs + auth JWT (rôles) + quotas par IP</a:t>
                       </a:r>
                     </a:p>
                   </a:txBody>
@@ -7851,7 +7851,7 @@
                           </a:solidFill>
                           <a:latin typeface="Arial"/>
                         </a:rPr>
-                        <a:t>Polars, jointures spatiales IRIS</a:t>
+                        <a:t>Polars + sources réelles DVF / INSEE Filosofi</a:t>
                       </a:r>
                     </a:p>
                   </a:txBody>
@@ -7897,7 +7897,7 @@
                           </a:solidFill>
                           <a:latin typeface="Arial"/>
                         </a:rPr>
-                        <a:t>Parquet, index, p95 &lt; 4 ms</a:t>
+                        <a:t>Parquet, index, p95 &lt; 4 ms, qualité tracée</a:t>
                       </a:r>
                     </a:p>
                   </a:txBody>
@@ -9916,7 +9916,7 @@
                 </a:solidFill>
                 <a:latin typeface="Arial"/>
               </a:rPr>
-              <a:t>16</a:t>
+              <a:t>24</a:t>
             </a:r>
           </a:p>
           <a:p>
@@ -9935,7 +9935,7 @@
                 </a:solidFill>
                 <a:latin typeface="Arial"/>
               </a:rPr>
-              <a:t>sources Open Data intégrées</a:t>
+              <a:t>sources de données intégrées</a:t>
             </a:r>
           </a:p>
           <a:p>
@@ -11296,7 +11296,7 @@
                 <a:spcPts val="0"/>
               </a:spcBef>
               <a:spcAft>
-                <a:spcPts val="1100"/>
+                <a:spcPts val="1200"/>
               </a:spcAft>
             </a:pPr>
             <a:r>
@@ -11315,7 +11315,7 @@
                 </a:solidFill>
                 <a:latin typeface="Arial"/>
               </a:rPr>
-              <a:t>16 sources Open Data Paris </a:t>
+              <a:t>24 sources, 8 familles : </a:t>
             </a:r>
             <a:r>
               <a:rPr sz="1400" b="0">
@@ -11324,7 +11324,7 @@
                 </a:solidFill>
                 <a:latin typeface="Arial"/>
               </a:rPr>
-              <a:t>réparties en 8 familles : mobilité, éducation, logement, culture, santé, espaces verts, services publics, pression urbaine.</a:t>
+              <a:t>mobilité, éducation, logement, culture, santé, espaces verts, services publics, pression urbaine.</a:t>
             </a:r>
           </a:p>
           <a:p>
@@ -11333,7 +11333,7 @@
                 <a:spcPts val="0"/>
               </a:spcBef>
               <a:spcAft>
-                <a:spcPts val="1100"/>
+                <a:spcPts val="1200"/>
               </a:spcAft>
             </a:pPr>
             <a:r>
@@ -11352,7 +11352,7 @@
                 </a:solidFill>
                 <a:latin typeface="Arial"/>
               </a:rPr>
-              <a:t>Formats hétérogènes : </a:t>
+              <a:t>Sources réelles : </a:t>
             </a:r>
             <a:r>
               <a:rPr sz="1400" b="0">
@@ -11361,7 +11361,7 @@
                 </a:solidFill>
                 <a:latin typeface="Arial"/>
               </a:rPr>
-              <a:t>CSV (Vélib, Belib, écoles, logements sociaux, marchés…) et GeoJSON (arrondissements, IRIS, rues, bâtiments).</a:t>
+              <a:t>DVF 2023 (prix immobilier) et INSEE Filosofi 2020 (revenus) alimentent le cœur logement.</a:t>
             </a:r>
           </a:p>
           <a:p>
@@ -11370,7 +11370,7 @@
                 <a:spcPts val="0"/>
               </a:spcBef>
               <a:spcAft>
-                <a:spcPts val="1100"/>
+                <a:spcPts val="1200"/>
               </a:spcAft>
             </a:pPr>
             <a:r>
@@ -11398,7 +11398,7 @@
                 </a:solidFill>
                 <a:latin typeface="Arial"/>
               </a:rPr>
-              <a:t>point-in-polygon (ray-casting) sur les contours IRIS pour rattacher chaque point à son arrondissement, sans appel réseau.</a:t>
+              <a:t>point-in-polygon (ray-casting) sur les contours IRIS, sans appel réseau ; fallback API adresse.data.gouv.fr.</a:t>
             </a:r>
           </a:p>
           <a:p>
@@ -11407,7 +11407,7 @@
                 <a:spcPts val="0"/>
               </a:spcBef>
               <a:spcAft>
-                <a:spcPts val="1100"/>
+                <a:spcPts val="1200"/>
               </a:spcAft>
             </a:pPr>
             <a:r>
@@ -11426,7 +11426,7 @@
                 </a:solidFill>
                 <a:latin typeface="Arial"/>
               </a:rPr>
-              <a:t>Fallback : </a:t>
+              <a:t>Qualité tracée : </a:t>
             </a:r>
             <a:r>
               <a:rPr sz="1400" b="0">
@@ -11435,44 +11435,7 @@
                 </a:solidFill>
                 <a:latin typeface="Arial"/>
               </a:rPr>
-              <a:t>API adresse.data.gouv.fr/reverse si l'arrondissement reste introuvable.</a:t>
-            </a:r>
-          </a:p>
-          <a:p>
-            <a:pPr>
-              <a:spcBef>
-                <a:spcPts val="0"/>
-              </a:spcBef>
-              <a:spcAft>
-                <a:spcPts val="1100"/>
-              </a:spcAft>
-            </a:pPr>
-            <a:r>
-              <a:rPr sz="1400" b="1">
-                <a:solidFill>
-                  <a:srgbClr val="000091"/>
-                </a:solidFill>
-                <a:latin typeface="Arial"/>
-              </a:rPr>
-              <a:t>▪  </a:t>
-            </a:r>
-            <a:r>
-              <a:rPr sz="1400" b="1">
-                <a:solidFill>
-                  <a:srgbClr val="161616"/>
-                </a:solidFill>
-                <a:latin typeface="Arial"/>
-              </a:rPr>
-              <a:t>Qualité : </a:t>
-            </a:r>
-            <a:r>
-              <a:rPr sz="1400" b="0">
-                <a:solidFill>
-                  <a:srgbClr val="3A3A3A"/>
-                </a:solidFill>
-                <a:latin typeface="Arial"/>
-              </a:rPr>
-              <a:t>drapeau quality_flag (matched / geocoded_iris / geocoded_api / code_only) pour la traçabilité.</a:t>
+              <a:t>drapeaux quality_flag (rattachement) et data_source (réel / référence).</a:t>
             </a:r>
           </a:p>
         </p:txBody>
@@ -11632,7 +11595,7 @@
                 </a:solidFill>
                 <a:latin typeface="Arial"/>
               </a:rPr>
-              <a:t>   7 sources</a:t>
+              <a:t>   7</a:t>
             </a:r>
           </a:p>
           <a:p>
@@ -11651,6 +11614,34 @@
                 </a:solidFill>
                 <a:latin typeface="Arial"/>
               </a:rPr>
+              <a:t>Logement</a:t>
+            </a:r>
+            <a:r>
+              <a:rPr sz="1300" b="0">
+                <a:solidFill>
+                  <a:srgbClr val="3A3A3A"/>
+                </a:solidFill>
+                <a:latin typeface="Arial"/>
+              </a:rPr>
+              <a:t>   3</a:t>
+            </a:r>
+          </a:p>
+          <a:p>
+            <a:pPr algn="l">
+              <a:spcBef>
+                <a:spcPts val="0"/>
+              </a:spcBef>
+              <a:spcAft>
+                <a:spcPts val="600"/>
+              </a:spcAft>
+            </a:pPr>
+            <a:r>
+              <a:rPr sz="1300" b="1">
+                <a:solidFill>
+                  <a:srgbClr val="161616"/>
+                </a:solidFill>
+                <a:latin typeface="Arial"/>
+              </a:rPr>
               <a:t>Éducation</a:t>
             </a:r>
             <a:r>
@@ -11660,7 +11651,7 @@
                 </a:solidFill>
                 <a:latin typeface="Arial"/>
               </a:rPr>
-              <a:t>   3 sources</a:t>
+              <a:t>   3</a:t>
             </a:r>
           </a:p>
           <a:p>
@@ -11679,7 +11670,7 @@
                 </a:solidFill>
                 <a:latin typeface="Arial"/>
               </a:rPr>
-              <a:t>Logement</a:t>
+              <a:t>Espaces verts</a:t>
             </a:r>
             <a:r>
               <a:rPr sz="1300" b="0">
@@ -11688,7 +11679,7 @@
                 </a:solidFill>
                 <a:latin typeface="Arial"/>
               </a:rPr>
-              <a:t>   1 source</a:t>
+              <a:t>   3</a:t>
             </a:r>
           </a:p>
           <a:p>
@@ -11707,6 +11698,34 @@
                 </a:solidFill>
                 <a:latin typeface="Arial"/>
               </a:rPr>
+              <a:t>Services publics</a:t>
+            </a:r>
+            <a:r>
+              <a:rPr sz="1300" b="0">
+                <a:solidFill>
+                  <a:srgbClr val="3A3A3A"/>
+                </a:solidFill>
+                <a:latin typeface="Arial"/>
+              </a:rPr>
+              <a:t>   3</a:t>
+            </a:r>
+          </a:p>
+          <a:p>
+            <a:pPr algn="l">
+              <a:spcBef>
+                <a:spcPts val="0"/>
+              </a:spcBef>
+              <a:spcAft>
+                <a:spcPts val="600"/>
+              </a:spcAft>
+            </a:pPr>
+            <a:r>
+              <a:rPr sz="1300" b="1">
+                <a:solidFill>
+                  <a:srgbClr val="161616"/>
+                </a:solidFill>
+                <a:latin typeface="Arial"/>
+              </a:rPr>
               <a:t>Culture</a:t>
             </a:r>
             <a:r>
@@ -11716,7 +11735,7 @@
                 </a:solidFill>
                 <a:latin typeface="Arial"/>
               </a:rPr>
-              <a:t>   1 source</a:t>
+              <a:t>   2</a:t>
             </a:r>
           </a:p>
           <a:p>
@@ -11744,7 +11763,7 @@
                 </a:solidFill>
                 <a:latin typeface="Arial"/>
               </a:rPr>
-              <a:t>   1 source</a:t>
+              <a:t>   2</a:t>
             </a:r>
           </a:p>
           <a:p>
@@ -11763,7 +11782,7 @@
                 </a:solidFill>
                 <a:latin typeface="Arial"/>
               </a:rPr>
-              <a:t>Espaces verts</a:t>
+              <a:t>Pression urbaine</a:t>
             </a:r>
             <a:r>
               <a:rPr sz="1300" b="0">
@@ -11772,63 +11791,7 @@
                 </a:solidFill>
                 <a:latin typeface="Arial"/>
               </a:rPr>
-              <a:t>   1 source</a:t>
-            </a:r>
-          </a:p>
-          <a:p>
-            <a:pPr algn="l">
-              <a:spcBef>
-                <a:spcPts val="0"/>
-              </a:spcBef>
-              <a:spcAft>
-                <a:spcPts val="600"/>
-              </a:spcAft>
-            </a:pPr>
-            <a:r>
-              <a:rPr sz="1300" b="1">
-                <a:solidFill>
-                  <a:srgbClr val="161616"/>
-                </a:solidFill>
-                <a:latin typeface="Arial"/>
-              </a:rPr>
-              <a:t>Services publics</a:t>
-            </a:r>
-            <a:r>
-              <a:rPr sz="1300" b="0">
-                <a:solidFill>
-                  <a:srgbClr val="3A3A3A"/>
-                </a:solidFill>
-                <a:latin typeface="Arial"/>
-              </a:rPr>
-              <a:t>   1 source</a:t>
-            </a:r>
-          </a:p>
-          <a:p>
-            <a:pPr algn="l">
-              <a:spcBef>
-                <a:spcPts val="0"/>
-              </a:spcBef>
-              <a:spcAft>
-                <a:spcPts val="600"/>
-              </a:spcAft>
-            </a:pPr>
-            <a:r>
-              <a:rPr sz="1300" b="1">
-                <a:solidFill>
-                  <a:srgbClr val="161616"/>
-                </a:solidFill>
-                <a:latin typeface="Arial"/>
-              </a:rPr>
-              <a:t>Pression urbaine</a:t>
-            </a:r>
-            <a:r>
-              <a:rPr sz="1300" b="0">
-                <a:solidFill>
-                  <a:srgbClr val="3A3A3A"/>
-                </a:solidFill>
-                <a:latin typeface="Arial"/>
-              </a:rPr>
-              <a:t>   1 source</a:t>
+              <a:t>   1</a:t>
             </a:r>
           </a:p>
         </p:txBody>
@@ -14393,7 +14356,7 @@
                 </a:solidFill>
                 <a:latin typeface="Arial"/>
               </a:rPr>
-              <a:t>FastAPI (ASGI, Pydantic v2), performance et documentation automatique.</a:t>
+              <a:t>FastAPI (ASGI, Pydantic v2), documentation auto (Swagger /docs).</a:t>
             </a:r>
           </a:p>
           <a:p>
@@ -14430,7 +14393,7 @@
                 </a:solidFill>
                 <a:latin typeface="Arial"/>
               </a:rPr>
-              <a:t>health, catalog, datamarts, pipeline, events, repo.</a:t>
+              <a:t>health, auth, catalog, datamarts, pipeline, events, repo.</a:t>
             </a:r>
           </a:p>
           <a:p>
@@ -14458,7 +14421,7 @@
                 </a:solidFill>
                 <a:latin typeface="Arial"/>
               </a:rPr>
-              <a:t>Données accessibles : </a:t>
+              <a:t>Authentification JWT : </a:t>
             </a:r>
             <a:r>
               <a:rPr sz="1300" b="0">
@@ -14467,7 +14430,7 @@
                 </a:solidFill>
                 <a:latin typeface="Arial"/>
               </a:rPr>
-              <a:t>dashboard, timeline, GeoJSON par granularité, événements.</a:t>
+              <a:t>OAuth2, rôles viewer / admin, jeton signé HS256 (60 min).</a:t>
             </a:r>
           </a:p>
           <a:p>
@@ -14495,7 +14458,7 @@
                 </a:solidFill>
                 <a:latin typeface="Arial"/>
               </a:rPr>
-              <a:t>Documentation : </a:t>
+              <a:t>Autorisations &amp; quotas : </a:t>
             </a:r>
             <a:r>
               <a:rPr sz="1300" b="0">
@@ -14504,7 +14467,7 @@
                 </a:solidFill>
                 <a:latin typeface="Arial"/>
               </a:rPr>
-              <a:t>Swagger interactif sur /docs, schéma OpenAPI sur /openapi.json.</a:t>
+              <a:t>route admin protégée ; limite par IP (anonyme 120, connecté 600 req/min → 429).</a:t>
             </a:r>
           </a:p>
           <a:p>
@@ -14532,7 +14495,7 @@
                 </a:solidFill>
                 <a:latin typeface="Arial"/>
               </a:rPr>
-              <a:t>Inter-services : </a:t>
+              <a:t>CORS restreint : </a:t>
             </a:r>
             <a:r>
               <a:rPr sz="1300" b="0">
@@ -14541,7 +14504,7 @@
                 </a:solidFill>
                 <a:latin typeface="Arial"/>
               </a:rPr>
-              <a:t>CORS configuré ; briques d'authentification (python-jose / passlib) intégrées.</a:t>
+              <a:t>à l'origine du frontend (variable UDE_CORS_ORIGINS).</a:t>
             </a:r>
           </a:p>
         </p:txBody>

</xml_diff>

<commit_message>
feat(infra,api): add C1.4 resilience and filterable datamarts API
- docker-compose: healthchecks, named volumes, ordered startup (service_healthy)
- API: filterable /datamarts/dashboard (arrondissement, score_min, sort)
- speaker notes with 10-min timing in soutenance deck
- ADR 0001 documenting architecture decisions C1.1 to C2.4
</commit_message>
<xml_diff>
--- a/soutenance.pptx
+++ b/soutenance.pptx
@@ -120,6 +120,1476 @@
     </a:lvl9pPr>
   </p:defaultTextStyle>
 </p:presentation>
+</file>
+
+<file path=ppt/notesMasters/notesMaster1.xml><?xml version="1.0" encoding="utf-8"?>
+<p:notesMaster xmlns:a="http://schemas.openxmlformats.org/drawingml/2006/main" xmlns:p="http://schemas.openxmlformats.org/presentationml/2006/main" xmlns:r="http://schemas.openxmlformats.org/officeDocument/2006/relationships">
+  <p:cSld>
+    <p:bg>
+      <p:bgRef idx="1001">
+        <a:schemeClr val="bg1"/>
+      </p:bgRef>
+    </p:bg>
+    <p:spTree>
+      <p:nvGrpSpPr>
+        <p:cNvPr id="1" name=""/>
+        <p:cNvGrpSpPr/>
+        <p:nvPr/>
+      </p:nvGrpSpPr>
+      <p:grpSpPr>
+        <a:xfrm>
+          <a:off x="0" y="0"/>
+          <a:ext cx="0" cy="0"/>
+          <a:chOff x="0" y="0"/>
+          <a:chExt cx="0" cy="0"/>
+        </a:xfrm>
+      </p:grpSpPr>
+      <p:sp>
+        <p:nvSpPr>
+          <p:cNvPr id="2" name="Header Placeholder 1"/>
+          <p:cNvSpPr>
+            <a:spLocks noGrp="1"/>
+          </p:cNvSpPr>
+          <p:nvPr>
+            <p:ph type="hdr" sz="quarter"/>
+          </p:nvPr>
+        </p:nvSpPr>
+        <p:spPr>
+          <a:xfrm>
+            <a:off x="0" y="0"/>
+            <a:ext cx="2971800" cy="457200"/>
+          </a:xfrm>
+          <a:prstGeom prst="rect">
+            <a:avLst/>
+          </a:prstGeom>
+        </p:spPr>
+        <p:txBody>
+          <a:bodyPr vert="horz" lIns="91440" tIns="45720" rIns="91440" bIns="45720" rtlCol="0"/>
+          <a:lstStyle>
+            <a:lvl1pPr algn="l">
+              <a:defRPr sz="1200"/>
+            </a:lvl1pPr>
+          </a:lstStyle>
+          <a:p>
+            <a:endParaRPr lang="en-US"/>
+          </a:p>
+        </p:txBody>
+      </p:sp>
+      <p:sp>
+        <p:nvSpPr>
+          <p:cNvPr id="3" name="Date Placeholder 2"/>
+          <p:cNvSpPr>
+            <a:spLocks noGrp="1"/>
+          </p:cNvSpPr>
+          <p:nvPr>
+            <p:ph type="dt" idx="1"/>
+          </p:nvPr>
+        </p:nvSpPr>
+        <p:spPr>
+          <a:xfrm>
+            <a:off x="3884613" y="0"/>
+            <a:ext cx="2971800" cy="457200"/>
+          </a:xfrm>
+          <a:prstGeom prst="rect">
+            <a:avLst/>
+          </a:prstGeom>
+        </p:spPr>
+        <p:txBody>
+          <a:bodyPr vert="horz" lIns="91440" tIns="45720" rIns="91440" bIns="45720" rtlCol="0"/>
+          <a:lstStyle>
+            <a:lvl1pPr algn="r">
+              <a:defRPr sz="1200"/>
+            </a:lvl1pPr>
+          </a:lstStyle>
+          <a:p>
+            <a:fld id="{0F89C1C7-3DCD-1040-A9CF-14679D8B5DDD}" type="datetimeFigureOut">
+              <a:rPr lang="en-US" smtClean="0"/>
+              <a:t>10/17/16</a:t>
+            </a:fld>
+            <a:endParaRPr lang="en-US"/>
+          </a:p>
+        </p:txBody>
+      </p:sp>
+      <p:sp>
+        <p:nvSpPr>
+          <p:cNvPr id="4" name="Slide Image Placeholder 3"/>
+          <p:cNvSpPr>
+            <a:spLocks noGrp="1" noRot="1" noChangeAspect="1"/>
+          </p:cNvSpPr>
+          <p:nvPr>
+            <p:ph type="sldImg" idx="2"/>
+          </p:nvPr>
+        </p:nvSpPr>
+        <p:spPr>
+          <a:xfrm>
+            <a:off x="1143000" y="685800"/>
+            <a:ext cx="4572000" cy="3429000"/>
+          </a:xfrm>
+          <a:prstGeom prst="rect">
+            <a:avLst/>
+          </a:prstGeom>
+          <a:noFill/>
+          <a:ln w="12700">
+            <a:solidFill>
+              <a:prstClr val="black"/>
+            </a:solidFill>
+          </a:ln>
+        </p:spPr>
+        <p:txBody>
+          <a:bodyPr vert="horz" lIns="91440" tIns="45720" rIns="91440" bIns="45720" rtlCol="0" anchor="ctr"/>
+          <a:lstStyle/>
+          <a:p>
+            <a:endParaRPr lang="en-US"/>
+          </a:p>
+        </p:txBody>
+      </p:sp>
+      <p:sp>
+        <p:nvSpPr>
+          <p:cNvPr id="5" name="Notes Placeholder 4"/>
+          <p:cNvSpPr>
+            <a:spLocks noGrp="1"/>
+          </p:cNvSpPr>
+          <p:nvPr>
+            <p:ph type="body" sz="quarter" idx="3"/>
+          </p:nvPr>
+        </p:nvSpPr>
+        <p:spPr>
+          <a:xfrm>
+            <a:off x="685800" y="4343400"/>
+            <a:ext cx="5486400" cy="4114800"/>
+          </a:xfrm>
+          <a:prstGeom prst="rect">
+            <a:avLst/>
+          </a:prstGeom>
+        </p:spPr>
+        <p:txBody>
+          <a:bodyPr vert="horz" lIns="91440" tIns="45720" rIns="91440" bIns="45720" rtlCol="0"/>
+          <a:lstStyle/>
+          <a:p>
+            <a:pPr lvl="0"/>
+            <a:r>
+              <a:rPr lang="en-US" smtClean="0"/>
+              <a:t>Click to edit Master text styles</a:t>
+            </a:r>
+          </a:p>
+          <a:p>
+            <a:pPr lvl="1"/>
+            <a:r>
+              <a:rPr lang="en-US" smtClean="0"/>
+              <a:t>Second level</a:t>
+            </a:r>
+          </a:p>
+          <a:p>
+            <a:pPr lvl="2"/>
+            <a:r>
+              <a:rPr lang="en-US" smtClean="0"/>
+              <a:t>Third level</a:t>
+            </a:r>
+          </a:p>
+          <a:p>
+            <a:pPr lvl="3"/>
+            <a:r>
+              <a:rPr lang="en-US" smtClean="0"/>
+              <a:t>Fourth level</a:t>
+            </a:r>
+          </a:p>
+          <a:p>
+            <a:pPr lvl="4"/>
+            <a:r>
+              <a:rPr lang="en-US" smtClean="0"/>
+              <a:t>Fifth level</a:t>
+            </a:r>
+            <a:endParaRPr lang="en-US"/>
+          </a:p>
+        </p:txBody>
+      </p:sp>
+      <p:sp>
+        <p:nvSpPr>
+          <p:cNvPr id="6" name="Footer Placeholder 5"/>
+          <p:cNvSpPr>
+            <a:spLocks noGrp="1"/>
+          </p:cNvSpPr>
+          <p:nvPr>
+            <p:ph type="ftr" sz="quarter" idx="4"/>
+          </p:nvPr>
+        </p:nvSpPr>
+        <p:spPr>
+          <a:xfrm>
+            <a:off x="0" y="8685213"/>
+            <a:ext cx="2971800" cy="457200"/>
+          </a:xfrm>
+          <a:prstGeom prst="rect">
+            <a:avLst/>
+          </a:prstGeom>
+        </p:spPr>
+        <p:txBody>
+          <a:bodyPr vert="horz" lIns="91440" tIns="45720" rIns="91440" bIns="45720" rtlCol="0" anchor="b"/>
+          <a:lstStyle>
+            <a:lvl1pPr algn="l">
+              <a:defRPr sz="1200"/>
+            </a:lvl1pPr>
+          </a:lstStyle>
+          <a:p>
+            <a:endParaRPr lang="en-US"/>
+          </a:p>
+        </p:txBody>
+      </p:sp>
+      <p:sp>
+        <p:nvSpPr>
+          <p:cNvPr id="7" name="Slide Number Placeholder 6"/>
+          <p:cNvSpPr>
+            <a:spLocks noGrp="1"/>
+          </p:cNvSpPr>
+          <p:nvPr>
+            <p:ph type="sldNum" sz="quarter" idx="5"/>
+          </p:nvPr>
+        </p:nvSpPr>
+        <p:spPr>
+          <a:xfrm>
+            <a:off x="3884613" y="8685213"/>
+            <a:ext cx="2971800" cy="457200"/>
+          </a:xfrm>
+          <a:prstGeom prst="rect">
+            <a:avLst/>
+          </a:prstGeom>
+        </p:spPr>
+        <p:txBody>
+          <a:bodyPr vert="horz" lIns="91440" tIns="45720" rIns="91440" bIns="45720" rtlCol="0" anchor="b"/>
+          <a:lstStyle>
+            <a:lvl1pPr algn="r">
+              <a:defRPr sz="1200"/>
+            </a:lvl1pPr>
+          </a:lstStyle>
+          <a:p>
+            <a:fld id="{BB5E49A5-4136-284D-997B-48E1D791AD67}" type="slidenum">
+              <a:rPr lang="en-US" smtClean="0"/>
+              <a:t>‹#›</a:t>
+            </a:fld>
+            <a:endParaRPr lang="en-US"/>
+          </a:p>
+        </p:txBody>
+      </p:sp>
+    </p:spTree>
+    <p:extLst>
+      <p:ext uri="{BB962C8B-B14F-4D97-AF65-F5344CB8AC3E}">
+        <p14:creationId xmlns:p14="http://schemas.microsoft.com/office/powerpoint/2010/main" val="2623252185"/>
+      </p:ext>
+    </p:extLst>
+  </p:cSld>
+  <p:clrMap bg1="lt1" tx1="dk1" bg2="lt2" tx2="dk2" accent1="accent1" accent2="accent2" accent3="accent3" accent4="accent4" accent5="accent5" accent6="accent6" hlink="hlink" folHlink="folHlink"/>
+  <p:notesStyle>
+    <a:lvl1pPr marL="0" algn="l" defTabSz="457200" rtl="0" eaLnBrk="1" latinLnBrk="0" hangingPunct="1">
+      <a:defRPr sz="1200" kern="1200">
+        <a:solidFill>
+          <a:schemeClr val="tx1"/>
+        </a:solidFill>
+        <a:latin typeface="+mn-lt"/>
+        <a:ea typeface="+mn-ea"/>
+        <a:cs typeface="+mn-cs"/>
+      </a:defRPr>
+    </a:lvl1pPr>
+    <a:lvl2pPr marL="457200" algn="l" defTabSz="457200" rtl="0" eaLnBrk="1" latinLnBrk="0" hangingPunct="1">
+      <a:defRPr sz="1200" kern="1200">
+        <a:solidFill>
+          <a:schemeClr val="tx1"/>
+        </a:solidFill>
+        <a:latin typeface="+mn-lt"/>
+        <a:ea typeface="+mn-ea"/>
+        <a:cs typeface="+mn-cs"/>
+      </a:defRPr>
+    </a:lvl2pPr>
+    <a:lvl3pPr marL="914400" algn="l" defTabSz="457200" rtl="0" eaLnBrk="1" latinLnBrk="0" hangingPunct="1">
+      <a:defRPr sz="1200" kern="1200">
+        <a:solidFill>
+          <a:schemeClr val="tx1"/>
+        </a:solidFill>
+        <a:latin typeface="+mn-lt"/>
+        <a:ea typeface="+mn-ea"/>
+        <a:cs typeface="+mn-cs"/>
+      </a:defRPr>
+    </a:lvl3pPr>
+    <a:lvl4pPr marL="1371600" algn="l" defTabSz="457200" rtl="0" eaLnBrk="1" latinLnBrk="0" hangingPunct="1">
+      <a:defRPr sz="1200" kern="1200">
+        <a:solidFill>
+          <a:schemeClr val="tx1"/>
+        </a:solidFill>
+        <a:latin typeface="+mn-lt"/>
+        <a:ea typeface="+mn-ea"/>
+        <a:cs typeface="+mn-cs"/>
+      </a:defRPr>
+    </a:lvl4pPr>
+    <a:lvl5pPr marL="1828800" algn="l" defTabSz="457200" rtl="0" eaLnBrk="1" latinLnBrk="0" hangingPunct="1">
+      <a:defRPr sz="1200" kern="1200">
+        <a:solidFill>
+          <a:schemeClr val="tx1"/>
+        </a:solidFill>
+        <a:latin typeface="+mn-lt"/>
+        <a:ea typeface="+mn-ea"/>
+        <a:cs typeface="+mn-cs"/>
+      </a:defRPr>
+    </a:lvl5pPr>
+    <a:lvl6pPr marL="2286000" algn="l" defTabSz="457200" rtl="0" eaLnBrk="1" latinLnBrk="0" hangingPunct="1">
+      <a:defRPr sz="1200" kern="1200">
+        <a:solidFill>
+          <a:schemeClr val="tx1"/>
+        </a:solidFill>
+        <a:latin typeface="+mn-lt"/>
+        <a:ea typeface="+mn-ea"/>
+        <a:cs typeface="+mn-cs"/>
+      </a:defRPr>
+    </a:lvl6pPr>
+    <a:lvl7pPr marL="2743200" algn="l" defTabSz="457200" rtl="0" eaLnBrk="1" latinLnBrk="0" hangingPunct="1">
+      <a:defRPr sz="1200" kern="1200">
+        <a:solidFill>
+          <a:schemeClr val="tx1"/>
+        </a:solidFill>
+        <a:latin typeface="+mn-lt"/>
+        <a:ea typeface="+mn-ea"/>
+        <a:cs typeface="+mn-cs"/>
+      </a:defRPr>
+    </a:lvl7pPr>
+    <a:lvl8pPr marL="3200400" algn="l" defTabSz="457200" rtl="0" eaLnBrk="1" latinLnBrk="0" hangingPunct="1">
+      <a:defRPr sz="1200" kern="1200">
+        <a:solidFill>
+          <a:schemeClr val="tx1"/>
+        </a:solidFill>
+        <a:latin typeface="+mn-lt"/>
+        <a:ea typeface="+mn-ea"/>
+        <a:cs typeface="+mn-cs"/>
+      </a:defRPr>
+    </a:lvl8pPr>
+    <a:lvl9pPr marL="3657600" algn="l" defTabSz="457200" rtl="0" eaLnBrk="1" latinLnBrk="0" hangingPunct="1">
+      <a:defRPr sz="1200" kern="1200">
+        <a:solidFill>
+          <a:schemeClr val="tx1"/>
+        </a:solidFill>
+        <a:latin typeface="+mn-lt"/>
+        <a:ea typeface="+mn-ea"/>
+        <a:cs typeface="+mn-cs"/>
+      </a:defRPr>
+    </a:lvl9pPr>
+  </p:notesStyle>
+</p:notesMaster>
+</file>
+
+<file path=ppt/notesSlides/notesSlide1.xml><?xml version="1.0" encoding="utf-8"?>
+<p:notes xmlns:a="http://schemas.openxmlformats.org/drawingml/2006/main" xmlns:p="http://schemas.openxmlformats.org/presentationml/2006/main" xmlns:r="http://schemas.openxmlformats.org/officeDocument/2006/relationships">
+  <p:cSld>
+    <p:spTree>
+      <p:nvGrpSpPr>
+        <p:cNvPr id="1" name=""/>
+        <p:cNvGrpSpPr/>
+        <p:nvPr/>
+      </p:nvGrpSpPr>
+      <p:grpSpPr>
+        <a:xfrm>
+          <a:off x="0" y="0"/>
+          <a:ext cx="0" cy="0"/>
+          <a:chOff x="0" y="0"/>
+          <a:chExt cx="0" cy="0"/>
+        </a:xfrm>
+      </p:grpSpPr>
+      <p:sp>
+        <p:nvSpPr>
+          <p:cNvPr id="2" name="Slide Image Placeholder 1"/>
+          <p:cNvSpPr>
+            <a:spLocks noGrp="1"/>
+          </p:cNvSpPr>
+          <p:nvPr>
+            <p:ph type="sldImg" idx="2"/>
+          </p:nvPr>
+        </p:nvSpPr>
+        <p:spPr/>
+      </p:sp>
+      <p:sp>
+        <p:nvSpPr>
+          <p:cNvPr id="3" name="Notes Placeholder 2"/>
+          <p:cNvSpPr>
+            <a:spLocks noGrp="1"/>
+          </p:cNvSpPr>
+          <p:nvPr>
+            <p:ph type="body" idx="3" sz="quarter"/>
+          </p:nvPr>
+        </p:nvSpPr>
+        <p:spPr/>
+        <p:txBody>
+          <a:bodyPr/>
+          <a:lstStyle/>
+          <a:p>
+            <a:r>
+              <a:t>[~0:30] Accroche : Paris, le logement, des donnees dispersees. On a construit l'observatoire qui les reunit.</a:t>
+            </a:r>
+          </a:p>
+        </p:txBody>
+      </p:sp>
+      <p:sp>
+        <p:nvSpPr>
+          <p:cNvPr id="4" name="Slide Number Placeholder 3"/>
+          <p:cNvSpPr>
+            <a:spLocks noGrp="1"/>
+          </p:cNvSpPr>
+          <p:nvPr>
+            <p:ph type="sldNum" idx="5" sz="quarter"/>
+          </p:nvPr>
+        </p:nvSpPr>
+        <p:spPr/>
+      </p:sp>
+    </p:spTree>
+  </p:cSld>
+  <p:clrMapOvr>
+    <a:masterClrMapping/>
+  </p:clrMapOvr>
+</p:notes>
+</file>
+
+<file path=ppt/notesSlides/notesSlide10.xml><?xml version="1.0" encoding="utf-8"?>
+<p:notes xmlns:a="http://schemas.openxmlformats.org/drawingml/2006/main" xmlns:p="http://schemas.openxmlformats.org/presentationml/2006/main" xmlns:r="http://schemas.openxmlformats.org/officeDocument/2006/relationships">
+  <p:cSld>
+    <p:spTree>
+      <p:nvGrpSpPr>
+        <p:cNvPr id="1" name=""/>
+        <p:cNvGrpSpPr/>
+        <p:nvPr/>
+      </p:nvGrpSpPr>
+      <p:grpSpPr>
+        <a:xfrm>
+          <a:off x="0" y="0"/>
+          <a:ext cx="0" cy="0"/>
+          <a:chOff x="0" y="0"/>
+          <a:chExt cx="0" cy="0"/>
+        </a:xfrm>
+      </p:grpSpPr>
+      <p:sp>
+        <p:nvSpPr>
+          <p:cNvPr id="2" name="Slide Image Placeholder 1"/>
+          <p:cNvSpPr>
+            <a:spLocks noGrp="1"/>
+          </p:cNvSpPr>
+          <p:nvPr>
+            <p:ph type="sldImg" idx="2"/>
+          </p:nvPr>
+        </p:nvSpPr>
+        <p:spPr/>
+      </p:sp>
+      <p:sp>
+        <p:nvSpPr>
+          <p:cNvPr id="3" name="Notes Placeholder 2"/>
+          <p:cNvSpPr>
+            <a:spLocks noGrp="1"/>
+          </p:cNvSpPr>
+          <p:nvPr>
+            <p:ph type="body" idx="3" sz="quarter"/>
+          </p:nvPr>
+        </p:nvSpPr>
+        <p:spPr/>
+        <p:txBody>
+          <a:bodyPr/>
+          <a:lstStyle/>
+          <a:p>
+            <a:r>
+              <a:t>[~0:30] C2.2 : Kafka temps reel vers Cassandra.</a:t>
+            </a:r>
+          </a:p>
+        </p:txBody>
+      </p:sp>
+      <p:sp>
+        <p:nvSpPr>
+          <p:cNvPr id="4" name="Slide Number Placeholder 3"/>
+          <p:cNvSpPr>
+            <a:spLocks noGrp="1"/>
+          </p:cNvSpPr>
+          <p:nvPr>
+            <p:ph type="sldNum" idx="5" sz="quarter"/>
+          </p:nvPr>
+        </p:nvSpPr>
+        <p:spPr/>
+      </p:sp>
+    </p:spTree>
+  </p:cSld>
+  <p:clrMapOvr>
+    <a:masterClrMapping/>
+  </p:clrMapOvr>
+</p:notes>
+</file>
+
+<file path=ppt/notesSlides/notesSlide11.xml><?xml version="1.0" encoding="utf-8"?>
+<p:notes xmlns:a="http://schemas.openxmlformats.org/drawingml/2006/main" xmlns:p="http://schemas.openxmlformats.org/presentationml/2006/main" xmlns:r="http://schemas.openxmlformats.org/officeDocument/2006/relationships">
+  <p:cSld>
+    <p:spTree>
+      <p:nvGrpSpPr>
+        <p:cNvPr id="1" name=""/>
+        <p:cNvGrpSpPr/>
+        <p:nvPr/>
+      </p:nvGrpSpPr>
+      <p:grpSpPr>
+        <a:xfrm>
+          <a:off x="0" y="0"/>
+          <a:ext cx="0" cy="0"/>
+          <a:chOff x="0" y="0"/>
+          <a:chExt cx="0" cy="0"/>
+        </a:xfrm>
+      </p:grpSpPr>
+      <p:sp>
+        <p:nvSpPr>
+          <p:cNvPr id="2" name="Slide Image Placeholder 1"/>
+          <p:cNvSpPr>
+            <a:spLocks noGrp="1"/>
+          </p:cNvSpPr>
+          <p:nvPr>
+            <p:ph type="sldImg" idx="2"/>
+          </p:nvPr>
+        </p:nvSpPr>
+        <p:spPr/>
+      </p:sp>
+      <p:sp>
+        <p:nvSpPr>
+          <p:cNvPr id="3" name="Notes Placeholder 2"/>
+          <p:cNvSpPr>
+            <a:spLocks noGrp="1"/>
+          </p:cNvSpPr>
+          <p:nvPr>
+            <p:ph type="body" idx="3" sz="quarter"/>
+          </p:nvPr>
+        </p:nvSpPr>
+        <p:spPr/>
+        <p:txBody>
+          <a:bodyPr/>
+          <a:lstStyle/>
+          <a:p>
+            <a:r>
+              <a:t>[~0:40] C2.3/C2.4 : fusion sources reelles, Parquet, index, qualite tracee.</a:t>
+            </a:r>
+          </a:p>
+        </p:txBody>
+      </p:sp>
+      <p:sp>
+        <p:nvSpPr>
+          <p:cNvPr id="4" name="Slide Number Placeholder 3"/>
+          <p:cNvSpPr>
+            <a:spLocks noGrp="1"/>
+          </p:cNvSpPr>
+          <p:nvPr>
+            <p:ph type="sldNum" idx="5" sz="quarter"/>
+          </p:nvPr>
+        </p:nvSpPr>
+        <p:spPr/>
+      </p:sp>
+    </p:spTree>
+  </p:cSld>
+  <p:clrMapOvr>
+    <a:masterClrMapping/>
+  </p:clrMapOvr>
+</p:notes>
+</file>
+
+<file path=ppt/notesSlides/notesSlide12.xml><?xml version="1.0" encoding="utf-8"?>
+<p:notes xmlns:a="http://schemas.openxmlformats.org/drawingml/2006/main" xmlns:p="http://schemas.openxmlformats.org/presentationml/2006/main" xmlns:r="http://schemas.openxmlformats.org/officeDocument/2006/relationships">
+  <p:cSld>
+    <p:spTree>
+      <p:nvGrpSpPr>
+        <p:cNvPr id="1" name=""/>
+        <p:cNvGrpSpPr/>
+        <p:nvPr/>
+      </p:nvGrpSpPr>
+      <p:grpSpPr>
+        <a:xfrm>
+          <a:off x="0" y="0"/>
+          <a:ext cx="0" cy="0"/>
+          <a:chOff x="0" y="0"/>
+          <a:chExt cx="0" cy="0"/>
+        </a:xfrm>
+      </p:grpSpPr>
+      <p:sp>
+        <p:nvSpPr>
+          <p:cNvPr id="2" name="Slide Image Placeholder 1"/>
+          <p:cNvSpPr>
+            <a:spLocks noGrp="1"/>
+          </p:cNvSpPr>
+          <p:nvPr>
+            <p:ph type="sldImg" idx="2"/>
+          </p:nvPr>
+        </p:nvSpPr>
+        <p:spPr/>
+      </p:sp>
+      <p:sp>
+        <p:nvSpPr>
+          <p:cNvPr id="3" name="Notes Placeholder 2"/>
+          <p:cNvSpPr>
+            <a:spLocks noGrp="1"/>
+          </p:cNvSpPr>
+          <p:nvPr>
+            <p:ph type="body" idx="3" sz="quarter"/>
+          </p:nvPr>
+        </p:nvSpPr>
+        <p:spPr/>
+        <p:txBody>
+          <a:bodyPr/>
+          <a:lstStyle/>
+          <a:p>
+            <a:r>
+              <a:t>[~0:40] Indicateurs Gold dont l'accessibilite prix/revenus (KPI demande).</a:t>
+            </a:r>
+          </a:p>
+        </p:txBody>
+      </p:sp>
+      <p:sp>
+        <p:nvSpPr>
+          <p:cNvPr id="4" name="Slide Number Placeholder 3"/>
+          <p:cNvSpPr>
+            <a:spLocks noGrp="1"/>
+          </p:cNvSpPr>
+          <p:nvPr>
+            <p:ph type="sldNum" idx="5" sz="quarter"/>
+          </p:nvPr>
+        </p:nvSpPr>
+        <p:spPr/>
+      </p:sp>
+    </p:spTree>
+  </p:cSld>
+  <p:clrMapOvr>
+    <a:masterClrMapping/>
+  </p:clrMapOvr>
+</p:notes>
+</file>
+
+<file path=ppt/notesSlides/notesSlide13.xml><?xml version="1.0" encoding="utf-8"?>
+<p:notes xmlns:a="http://schemas.openxmlformats.org/drawingml/2006/main" xmlns:p="http://schemas.openxmlformats.org/presentationml/2006/main" xmlns:r="http://schemas.openxmlformats.org/officeDocument/2006/relationships">
+  <p:cSld>
+    <p:spTree>
+      <p:nvGrpSpPr>
+        <p:cNvPr id="1" name=""/>
+        <p:cNvGrpSpPr/>
+        <p:nvPr/>
+      </p:nvGrpSpPr>
+      <p:grpSpPr>
+        <a:xfrm>
+          <a:off x="0" y="0"/>
+          <a:ext cx="0" cy="0"/>
+          <a:chOff x="0" y="0"/>
+          <a:chExt cx="0" cy="0"/>
+        </a:xfrm>
+      </p:grpSpPr>
+      <p:sp>
+        <p:nvSpPr>
+          <p:cNvPr id="2" name="Slide Image Placeholder 1"/>
+          <p:cNvSpPr>
+            <a:spLocks noGrp="1"/>
+          </p:cNvSpPr>
+          <p:nvPr>
+            <p:ph type="sldImg" idx="2"/>
+          </p:nvPr>
+        </p:nvSpPr>
+        <p:spPr/>
+      </p:sp>
+      <p:sp>
+        <p:nvSpPr>
+          <p:cNvPr id="3" name="Notes Placeholder 2"/>
+          <p:cNvSpPr>
+            <a:spLocks noGrp="1"/>
+          </p:cNvSpPr>
+          <p:nvPr>
+            <p:ph type="body" idx="3" sz="quarter"/>
+          </p:nvPr>
+        </p:nvSpPr>
+        <p:spPr/>
+        <p:txBody>
+          <a:bodyPr/>
+          <a:lstStyle/>
+          <a:p>
+            <a:r>
+              <a:t>[~1:00] DEMO LIVE : carte, choix d'un arrondissement, comparaison, theme sombre.</a:t>
+            </a:r>
+          </a:p>
+        </p:txBody>
+      </p:sp>
+      <p:sp>
+        <p:nvSpPr>
+          <p:cNvPr id="4" name="Slide Number Placeholder 3"/>
+          <p:cNvSpPr>
+            <a:spLocks noGrp="1"/>
+          </p:cNvSpPr>
+          <p:nvPr>
+            <p:ph type="sldNum" idx="5" sz="quarter"/>
+          </p:nvPr>
+        </p:nvSpPr>
+        <p:spPr/>
+      </p:sp>
+    </p:spTree>
+  </p:cSld>
+  <p:clrMapOvr>
+    <a:masterClrMapping/>
+  </p:clrMapOvr>
+</p:notes>
+</file>
+
+<file path=ppt/notesSlides/notesSlide14.xml><?xml version="1.0" encoding="utf-8"?>
+<p:notes xmlns:a="http://schemas.openxmlformats.org/drawingml/2006/main" xmlns:p="http://schemas.openxmlformats.org/presentationml/2006/main" xmlns:r="http://schemas.openxmlformats.org/officeDocument/2006/relationships">
+  <p:cSld>
+    <p:spTree>
+      <p:nvGrpSpPr>
+        <p:cNvPr id="1" name=""/>
+        <p:cNvGrpSpPr/>
+        <p:nvPr/>
+      </p:nvGrpSpPr>
+      <p:grpSpPr>
+        <a:xfrm>
+          <a:off x="0" y="0"/>
+          <a:ext cx="0" cy="0"/>
+          <a:chOff x="0" y="0"/>
+          <a:chExt cx="0" cy="0"/>
+        </a:xfrm>
+      </p:grpSpPr>
+      <p:sp>
+        <p:nvSpPr>
+          <p:cNvPr id="2" name="Slide Image Placeholder 1"/>
+          <p:cNvSpPr>
+            <a:spLocks noGrp="1"/>
+          </p:cNvSpPr>
+          <p:nvPr>
+            <p:ph type="sldImg" idx="2"/>
+          </p:nvPr>
+        </p:nvSpPr>
+        <p:spPr/>
+      </p:sp>
+      <p:sp>
+        <p:nvSpPr>
+          <p:cNvPr id="3" name="Notes Placeholder 2"/>
+          <p:cNvSpPr>
+            <a:spLocks noGrp="1"/>
+          </p:cNvSpPr>
+          <p:nvPr>
+            <p:ph type="body" idx="3" sz="quarter"/>
+          </p:nvPr>
+        </p:nvSpPr>
+        <p:spPr/>
+        <p:txBody>
+          <a:bodyPr/>
+          <a:lstStyle/>
+          <a:p>
+            <a:r>
+              <a:t>[Annexe] Accessibilite / theme sombre si question.</a:t>
+            </a:r>
+          </a:p>
+        </p:txBody>
+      </p:sp>
+      <p:sp>
+        <p:nvSpPr>
+          <p:cNvPr id="4" name="Slide Number Placeholder 3"/>
+          <p:cNvSpPr>
+            <a:spLocks noGrp="1"/>
+          </p:cNvSpPr>
+          <p:nvPr>
+            <p:ph type="sldNum" idx="5" sz="quarter"/>
+          </p:nvPr>
+        </p:nvSpPr>
+        <p:spPr/>
+      </p:sp>
+    </p:spTree>
+  </p:cSld>
+  <p:clrMapOvr>
+    <a:masterClrMapping/>
+  </p:clrMapOvr>
+</p:notes>
+</file>
+
+<file path=ppt/notesSlides/notesSlide15.xml><?xml version="1.0" encoding="utf-8"?>
+<p:notes xmlns:a="http://schemas.openxmlformats.org/drawingml/2006/main" xmlns:p="http://schemas.openxmlformats.org/presentationml/2006/main" xmlns:r="http://schemas.openxmlformats.org/officeDocument/2006/relationships">
+  <p:cSld>
+    <p:spTree>
+      <p:nvGrpSpPr>
+        <p:cNvPr id="1" name=""/>
+        <p:cNvGrpSpPr/>
+        <p:nvPr/>
+      </p:nvGrpSpPr>
+      <p:grpSpPr>
+        <a:xfrm>
+          <a:off x="0" y="0"/>
+          <a:ext cx="0" cy="0"/>
+          <a:chOff x="0" y="0"/>
+          <a:chExt cx="0" cy="0"/>
+        </a:xfrm>
+      </p:grpSpPr>
+      <p:sp>
+        <p:nvSpPr>
+          <p:cNvPr id="2" name="Slide Image Placeholder 1"/>
+          <p:cNvSpPr>
+            <a:spLocks noGrp="1"/>
+          </p:cNvSpPr>
+          <p:nvPr>
+            <p:ph type="sldImg" idx="2"/>
+          </p:nvPr>
+        </p:nvSpPr>
+        <p:spPr/>
+      </p:sp>
+      <p:sp>
+        <p:nvSpPr>
+          <p:cNvPr id="3" name="Notes Placeholder 2"/>
+          <p:cNvSpPr>
+            <a:spLocks noGrp="1"/>
+          </p:cNvSpPr>
+          <p:nvPr>
+            <p:ph type="body" idx="3" sz="quarter"/>
+          </p:nvPr>
+        </p:nvSpPr>
+        <p:spPr/>
+        <p:txBody>
+          <a:bodyPr/>
+          <a:lstStyle/>
+          <a:p>
+            <a:r>
+              <a:t>[~0:30] Grille : on coche C1.1 a C2.4.</a:t>
+            </a:r>
+          </a:p>
+        </p:txBody>
+      </p:sp>
+      <p:sp>
+        <p:nvSpPr>
+          <p:cNvPr id="4" name="Slide Number Placeholder 3"/>
+          <p:cNvSpPr>
+            <a:spLocks noGrp="1"/>
+          </p:cNvSpPr>
+          <p:nvPr>
+            <p:ph type="sldNum" idx="5" sz="quarter"/>
+          </p:nvPr>
+        </p:nvSpPr>
+        <p:spPr/>
+      </p:sp>
+    </p:spTree>
+  </p:cSld>
+  <p:clrMapOvr>
+    <a:masterClrMapping/>
+  </p:clrMapOvr>
+</p:notes>
+</file>
+
+<file path=ppt/notesSlides/notesSlide16.xml><?xml version="1.0" encoding="utf-8"?>
+<p:notes xmlns:a="http://schemas.openxmlformats.org/drawingml/2006/main" xmlns:p="http://schemas.openxmlformats.org/presentationml/2006/main" xmlns:r="http://schemas.openxmlformats.org/officeDocument/2006/relationships">
+  <p:cSld>
+    <p:spTree>
+      <p:nvGrpSpPr>
+        <p:cNvPr id="1" name=""/>
+        <p:cNvGrpSpPr/>
+        <p:nvPr/>
+      </p:nvGrpSpPr>
+      <p:grpSpPr>
+        <a:xfrm>
+          <a:off x="0" y="0"/>
+          <a:ext cx="0" cy="0"/>
+          <a:chOff x="0" y="0"/>
+          <a:chExt cx="0" cy="0"/>
+        </a:xfrm>
+      </p:grpSpPr>
+      <p:sp>
+        <p:nvSpPr>
+          <p:cNvPr id="2" name="Slide Image Placeholder 1"/>
+          <p:cNvSpPr>
+            <a:spLocks noGrp="1"/>
+          </p:cNvSpPr>
+          <p:nvPr>
+            <p:ph type="sldImg" idx="2"/>
+          </p:nvPr>
+        </p:nvSpPr>
+        <p:spPr/>
+      </p:sp>
+      <p:sp>
+        <p:nvSpPr>
+          <p:cNvPr id="3" name="Notes Placeholder 2"/>
+          <p:cNvSpPr>
+            <a:spLocks noGrp="1"/>
+          </p:cNvSpPr>
+          <p:nvPr>
+            <p:ph type="body" idx="3" sz="quarter"/>
+          </p:nvPr>
+        </p:nvSpPr>
+        <p:spPr/>
+        <p:txBody>
+          <a:bodyPr/>
+          <a:lstStyle/>
+          <a:p>
+            <a:r>
+              <a:t>[~0:30] Conclusion : solution complete, reelle, soignee. Merci. Questions.</a:t>
+            </a:r>
+          </a:p>
+        </p:txBody>
+      </p:sp>
+      <p:sp>
+        <p:nvSpPr>
+          <p:cNvPr id="4" name="Slide Number Placeholder 3"/>
+          <p:cNvSpPr>
+            <a:spLocks noGrp="1"/>
+          </p:cNvSpPr>
+          <p:nvPr>
+            <p:ph type="sldNum" idx="5" sz="quarter"/>
+          </p:nvPr>
+        </p:nvSpPr>
+        <p:spPr/>
+      </p:sp>
+    </p:spTree>
+  </p:cSld>
+  <p:clrMapOvr>
+    <a:masterClrMapping/>
+  </p:clrMapOvr>
+</p:notes>
+</file>
+
+<file path=ppt/notesSlides/notesSlide2.xml><?xml version="1.0" encoding="utf-8"?>
+<p:notes xmlns:a="http://schemas.openxmlformats.org/drawingml/2006/main" xmlns:p="http://schemas.openxmlformats.org/presentationml/2006/main" xmlns:r="http://schemas.openxmlformats.org/officeDocument/2006/relationships">
+  <p:cSld>
+    <p:spTree>
+      <p:nvGrpSpPr>
+        <p:cNvPr id="1" name=""/>
+        <p:cNvGrpSpPr/>
+        <p:nvPr/>
+      </p:nvGrpSpPr>
+      <p:grpSpPr>
+        <a:xfrm>
+          <a:off x="0" y="0"/>
+          <a:ext cx="0" cy="0"/>
+          <a:chOff x="0" y="0"/>
+          <a:chExt cx="0" cy="0"/>
+        </a:xfrm>
+      </p:grpSpPr>
+      <p:sp>
+        <p:nvSpPr>
+          <p:cNvPr id="2" name="Slide Image Placeholder 1"/>
+          <p:cNvSpPr>
+            <a:spLocks noGrp="1"/>
+          </p:cNvSpPr>
+          <p:nvPr>
+            <p:ph type="sldImg" idx="2"/>
+          </p:nvPr>
+        </p:nvSpPr>
+        <p:spPr/>
+      </p:sp>
+      <p:sp>
+        <p:nvSpPr>
+          <p:cNvPr id="3" name="Notes Placeholder 2"/>
+          <p:cNvSpPr>
+            <a:spLocks noGrp="1"/>
+          </p:cNvSpPr>
+          <p:nvPr>
+            <p:ph type="body" idx="3" sz="quarter"/>
+          </p:nvPr>
+        </p:nvSpPr>
+        <p:spPr/>
+        <p:txBody>
+          <a:bodyPr/>
+          <a:lstStyle/>
+          <a:p>
+            <a:r>
+              <a:t>[~0:20] Plan rapide. Annoncer la demo live a la fin.</a:t>
+            </a:r>
+          </a:p>
+        </p:txBody>
+      </p:sp>
+      <p:sp>
+        <p:nvSpPr>
+          <p:cNvPr id="4" name="Slide Number Placeholder 3"/>
+          <p:cNvSpPr>
+            <a:spLocks noGrp="1"/>
+          </p:cNvSpPr>
+          <p:nvPr>
+            <p:ph type="sldNum" idx="5" sz="quarter"/>
+          </p:nvPr>
+        </p:nvSpPr>
+        <p:spPr/>
+      </p:sp>
+    </p:spTree>
+  </p:cSld>
+  <p:clrMapOvr>
+    <a:masterClrMapping/>
+  </p:clrMapOvr>
+</p:notes>
+</file>
+
+<file path=ppt/notesSlides/notesSlide3.xml><?xml version="1.0" encoding="utf-8"?>
+<p:notes xmlns:a="http://schemas.openxmlformats.org/drawingml/2006/main" xmlns:p="http://schemas.openxmlformats.org/presentationml/2006/main" xmlns:r="http://schemas.openxmlformats.org/officeDocument/2006/relationships">
+  <p:cSld>
+    <p:spTree>
+      <p:nvGrpSpPr>
+        <p:cNvPr id="1" name=""/>
+        <p:cNvGrpSpPr/>
+        <p:nvPr/>
+      </p:nvGrpSpPr>
+      <p:grpSpPr>
+        <a:xfrm>
+          <a:off x="0" y="0"/>
+          <a:ext cx="0" cy="0"/>
+          <a:chOff x="0" y="0"/>
+          <a:chExt cx="0" cy="0"/>
+        </a:xfrm>
+      </p:grpSpPr>
+      <p:sp>
+        <p:nvSpPr>
+          <p:cNvPr id="2" name="Slide Image Placeholder 1"/>
+          <p:cNvSpPr>
+            <a:spLocks noGrp="1"/>
+          </p:cNvSpPr>
+          <p:nvPr>
+            <p:ph type="sldImg" idx="2"/>
+          </p:nvPr>
+        </p:nvSpPr>
+        <p:spPr/>
+      </p:sp>
+      <p:sp>
+        <p:nvSpPr>
+          <p:cNvPr id="3" name="Notes Placeholder 2"/>
+          <p:cNvSpPr>
+            <a:spLocks noGrp="1"/>
+          </p:cNvSpPr>
+          <p:nvPr>
+            <p:ph type="body" idx="3" sz="quarter"/>
+          </p:nvPr>
+        </p:nvSpPr>
+        <p:spPr/>
+        <p:txBody>
+          <a:bodyPr/>
+          <a:lstStyle/>
+          <a:p>
+            <a:r>
+              <a:t>[~1:00] Probleme metier + chiffres cles (24 sources, 20 arrondissements). Pourquoi une gouvernance en a besoin.</a:t>
+            </a:r>
+          </a:p>
+        </p:txBody>
+      </p:sp>
+      <p:sp>
+        <p:nvSpPr>
+          <p:cNvPr id="4" name="Slide Number Placeholder 3"/>
+          <p:cNvSpPr>
+            <a:spLocks noGrp="1"/>
+          </p:cNvSpPr>
+          <p:nvPr>
+            <p:ph type="sldNum" idx="5" sz="quarter"/>
+          </p:nvPr>
+        </p:nvSpPr>
+        <p:spPr/>
+      </p:sp>
+    </p:spTree>
+  </p:cSld>
+  <p:clrMapOvr>
+    <a:masterClrMapping/>
+  </p:clrMapOvr>
+</p:notes>
+</file>
+
+<file path=ppt/notesSlides/notesSlide4.xml><?xml version="1.0" encoding="utf-8"?>
+<p:notes xmlns:a="http://schemas.openxmlformats.org/drawingml/2006/main" xmlns:p="http://schemas.openxmlformats.org/presentationml/2006/main" xmlns:r="http://schemas.openxmlformats.org/officeDocument/2006/relationships">
+  <p:cSld>
+    <p:spTree>
+      <p:nvGrpSpPr>
+        <p:cNvPr id="1" name=""/>
+        <p:cNvGrpSpPr/>
+        <p:nvPr/>
+      </p:nvGrpSpPr>
+      <p:grpSpPr>
+        <a:xfrm>
+          <a:off x="0" y="0"/>
+          <a:ext cx="0" cy="0"/>
+          <a:chOff x="0" y="0"/>
+          <a:chExt cx="0" cy="0"/>
+        </a:xfrm>
+      </p:grpSpPr>
+      <p:sp>
+        <p:nvSpPr>
+          <p:cNvPr id="2" name="Slide Image Placeholder 1"/>
+          <p:cNvSpPr>
+            <a:spLocks noGrp="1"/>
+          </p:cNvSpPr>
+          <p:nvPr>
+            <p:ph type="sldImg" idx="2"/>
+          </p:nvPr>
+        </p:nvSpPr>
+        <p:spPr/>
+      </p:sp>
+      <p:sp>
+        <p:nvSpPr>
+          <p:cNvPr id="3" name="Notes Placeholder 2"/>
+          <p:cNvSpPr>
+            <a:spLocks noGrp="1"/>
+          </p:cNvSpPr>
+          <p:nvPr>
+            <p:ph type="body" idx="3" sz="quarter"/>
+          </p:nvPr>
+        </p:nvSpPr>
+        <p:spPr/>
+        <p:txBody>
+          <a:bodyPr/>
+          <a:lstStyle/>
+          <a:p>
+            <a:r>
+              <a:t>[~1:00] Le voyage de la donnee : Bronze/Silver/Gold, Polars, puis API et carte. Insister sur le bout-en-bout.</a:t>
+            </a:r>
+          </a:p>
+        </p:txBody>
+      </p:sp>
+      <p:sp>
+        <p:nvSpPr>
+          <p:cNvPr id="4" name="Slide Number Placeholder 3"/>
+          <p:cNvSpPr>
+            <a:spLocks noGrp="1"/>
+          </p:cNvSpPr>
+          <p:nvPr>
+            <p:ph type="sldNum" idx="5" sz="quarter"/>
+          </p:nvPr>
+        </p:nvSpPr>
+        <p:spPr/>
+      </p:sp>
+    </p:spTree>
+  </p:cSld>
+  <p:clrMapOvr>
+    <a:masterClrMapping/>
+  </p:clrMapOvr>
+</p:notes>
+</file>
+
+<file path=ppt/notesSlides/notesSlide5.xml><?xml version="1.0" encoding="utf-8"?>
+<p:notes xmlns:a="http://schemas.openxmlformats.org/drawingml/2006/main" xmlns:p="http://schemas.openxmlformats.org/presentationml/2006/main" xmlns:r="http://schemas.openxmlformats.org/officeDocument/2006/relationships">
+  <p:cSld>
+    <p:spTree>
+      <p:nvGrpSpPr>
+        <p:cNvPr id="1" name=""/>
+        <p:cNvGrpSpPr/>
+        <p:nvPr/>
+      </p:nvGrpSpPr>
+      <p:grpSpPr>
+        <a:xfrm>
+          <a:off x="0" y="0"/>
+          <a:ext cx="0" cy="0"/>
+          <a:chOff x="0" y="0"/>
+          <a:chExt cx="0" cy="0"/>
+        </a:xfrm>
+      </p:grpSpPr>
+      <p:sp>
+        <p:nvSpPr>
+          <p:cNvPr id="2" name="Slide Image Placeholder 1"/>
+          <p:cNvSpPr>
+            <a:spLocks noGrp="1"/>
+          </p:cNvSpPr>
+          <p:nvPr>
+            <p:ph type="sldImg" idx="2"/>
+          </p:nvPr>
+        </p:nvSpPr>
+        <p:spPr/>
+      </p:sp>
+      <p:sp>
+        <p:nvSpPr>
+          <p:cNvPr id="3" name="Notes Placeholder 2"/>
+          <p:cNvSpPr>
+            <a:spLocks noGrp="1"/>
+          </p:cNvSpPr>
+          <p:nvPr>
+            <p:ph type="body" idx="3" sz="quarter"/>
+          </p:nvPr>
+        </p:nvSpPr>
+        <p:spPr/>
+        <p:txBody>
+          <a:bodyPr/>
+          <a:lstStyle/>
+          <a:p>
+            <a:r>
+              <a:t>[~1:00] Sources : 24, equilibrees. Surtout : prix DVF et revenus INSEE REELS. Geocodage hors ligne.</a:t>
+            </a:r>
+          </a:p>
+        </p:txBody>
+      </p:sp>
+      <p:sp>
+        <p:nvSpPr>
+          <p:cNvPr id="4" name="Slide Number Placeholder 3"/>
+          <p:cNvSpPr>
+            <a:spLocks noGrp="1"/>
+          </p:cNvSpPr>
+          <p:nvPr>
+            <p:ph type="sldNum" idx="5" sz="quarter"/>
+          </p:nvPr>
+        </p:nvSpPr>
+        <p:spPr/>
+      </p:sp>
+    </p:spTree>
+  </p:cSld>
+  <p:clrMapOvr>
+    <a:masterClrMapping/>
+  </p:clrMapOvr>
+</p:notes>
+</file>
+
+<file path=ppt/notesSlides/notesSlide6.xml><?xml version="1.0" encoding="utf-8"?>
+<p:notes xmlns:a="http://schemas.openxmlformats.org/drawingml/2006/main" xmlns:p="http://schemas.openxmlformats.org/presentationml/2006/main" xmlns:r="http://schemas.openxmlformats.org/officeDocument/2006/relationships">
+  <p:cSld>
+    <p:spTree>
+      <p:nvGrpSpPr>
+        <p:cNvPr id="1" name=""/>
+        <p:cNvGrpSpPr/>
+        <p:nvPr/>
+      </p:nvGrpSpPr>
+      <p:grpSpPr>
+        <a:xfrm>
+          <a:off x="0" y="0"/>
+          <a:ext cx="0" cy="0"/>
+          <a:chOff x="0" y="0"/>
+          <a:chExt cx="0" cy="0"/>
+        </a:xfrm>
+      </p:grpSpPr>
+      <p:sp>
+        <p:nvSpPr>
+          <p:cNvPr id="2" name="Slide Image Placeholder 1"/>
+          <p:cNvSpPr>
+            <a:spLocks noGrp="1"/>
+          </p:cNvSpPr>
+          <p:nvPr>
+            <p:ph type="sldImg" idx="2"/>
+          </p:nvPr>
+        </p:nvSpPr>
+        <p:spPr/>
+      </p:sp>
+      <p:sp>
+        <p:nvSpPr>
+          <p:cNvPr id="3" name="Notes Placeholder 2"/>
+          <p:cNvSpPr>
+            <a:spLocks noGrp="1"/>
+          </p:cNvSpPr>
+          <p:nvPr>
+            <p:ph type="body" idx="3" sz="quarter"/>
+          </p:nvPr>
+        </p:nvSpPr>
+        <p:spPr/>
+        <p:txBody>
+          <a:bodyPr/>
+          <a:lstStyle/>
+          <a:p>
+            <a:r>
+              <a:t>[~0:40] C1.1 : etoile PostgreSQL + tests de charge (1190 req/s, p95 3,5 ms).</a:t>
+            </a:r>
+          </a:p>
+        </p:txBody>
+      </p:sp>
+      <p:sp>
+        <p:nvSpPr>
+          <p:cNvPr id="4" name="Slide Number Placeholder 3"/>
+          <p:cNvSpPr>
+            <a:spLocks noGrp="1"/>
+          </p:cNvSpPr>
+          <p:nvPr>
+            <p:ph type="sldNum" idx="5" sz="quarter"/>
+          </p:nvPr>
+        </p:nvSpPr>
+        <p:spPr/>
+      </p:sp>
+    </p:spTree>
+  </p:cSld>
+  <p:clrMapOvr>
+    <a:masterClrMapping/>
+  </p:clrMapOvr>
+</p:notes>
+</file>
+
+<file path=ppt/notesSlides/notesSlide7.xml><?xml version="1.0" encoding="utf-8"?>
+<p:notes xmlns:a="http://schemas.openxmlformats.org/drawingml/2006/main" xmlns:p="http://schemas.openxmlformats.org/presentationml/2006/main" xmlns:r="http://schemas.openxmlformats.org/officeDocument/2006/relationships">
+  <p:cSld>
+    <p:spTree>
+      <p:nvGrpSpPr>
+        <p:cNvPr id="1" name=""/>
+        <p:cNvGrpSpPr/>
+        <p:nvPr/>
+      </p:nvGrpSpPr>
+      <p:grpSpPr>
+        <a:xfrm>
+          <a:off x="0" y="0"/>
+          <a:ext cx="0" cy="0"/>
+          <a:chOff x="0" y="0"/>
+          <a:chExt cx="0" cy="0"/>
+        </a:xfrm>
+      </p:grpSpPr>
+      <p:sp>
+        <p:nvSpPr>
+          <p:cNvPr id="2" name="Slide Image Placeholder 1"/>
+          <p:cNvSpPr>
+            <a:spLocks noGrp="1"/>
+          </p:cNvSpPr>
+          <p:nvPr>
+            <p:ph type="sldImg" idx="2"/>
+          </p:nvPr>
+        </p:nvSpPr>
+        <p:spPr/>
+      </p:sp>
+      <p:sp>
+        <p:nvSpPr>
+          <p:cNvPr id="3" name="Notes Placeholder 2"/>
+          <p:cNvSpPr>
+            <a:spLocks noGrp="1"/>
+          </p:cNvSpPr>
+          <p:nvPr>
+            <p:ph type="body" idx="3" sz="quarter"/>
+          </p:nvPr>
+        </p:nvSpPr>
+        <p:spPr/>
+        <p:txBody>
+          <a:bodyPr/>
+          <a:lstStyle/>
+          <a:p>
+            <a:r>
+              <a:t>[~0:30] C1.2 : Cassandra pour le flux, tri par date, purge 7 jours.</a:t>
+            </a:r>
+          </a:p>
+        </p:txBody>
+      </p:sp>
+      <p:sp>
+        <p:nvSpPr>
+          <p:cNvPr id="4" name="Slide Number Placeholder 3"/>
+          <p:cNvSpPr>
+            <a:spLocks noGrp="1"/>
+          </p:cNvSpPr>
+          <p:nvPr>
+            <p:ph type="sldNum" idx="5" sz="quarter"/>
+          </p:nvPr>
+        </p:nvSpPr>
+        <p:spPr/>
+      </p:sp>
+    </p:spTree>
+  </p:cSld>
+  <p:clrMapOvr>
+    <a:masterClrMapping/>
+  </p:clrMapOvr>
+</p:notes>
+</file>
+
+<file path=ppt/notesSlides/notesSlide8.xml><?xml version="1.0" encoding="utf-8"?>
+<p:notes xmlns:a="http://schemas.openxmlformats.org/drawingml/2006/main" xmlns:p="http://schemas.openxmlformats.org/presentationml/2006/main" xmlns:r="http://schemas.openxmlformats.org/officeDocument/2006/relationships">
+  <p:cSld>
+    <p:spTree>
+      <p:nvGrpSpPr>
+        <p:cNvPr id="1" name=""/>
+        <p:cNvGrpSpPr/>
+        <p:nvPr/>
+      </p:nvGrpSpPr>
+      <p:grpSpPr>
+        <a:xfrm>
+          <a:off x="0" y="0"/>
+          <a:ext cx="0" cy="0"/>
+          <a:chOff x="0" y="0"/>
+          <a:chExt cx="0" cy="0"/>
+        </a:xfrm>
+      </p:grpSpPr>
+      <p:sp>
+        <p:nvSpPr>
+          <p:cNvPr id="2" name="Slide Image Placeholder 1"/>
+          <p:cNvSpPr>
+            <a:spLocks noGrp="1"/>
+          </p:cNvSpPr>
+          <p:nvPr>
+            <p:ph type="sldImg" idx="2"/>
+          </p:nvPr>
+        </p:nvSpPr>
+        <p:spPr/>
+      </p:sp>
+      <p:sp>
+        <p:nvSpPr>
+          <p:cNvPr id="3" name="Notes Placeholder 2"/>
+          <p:cNvSpPr>
+            <a:spLocks noGrp="1"/>
+          </p:cNvSpPr>
+          <p:nvPr>
+            <p:ph type="body" idx="3" sz="quarter"/>
+          </p:nvPr>
+        </p:nvSpPr>
+        <p:spPr/>
+        <p:txBody>
+          <a:bodyPr/>
+          <a:lstStyle/>
+          <a:p>
+            <a:r>
+              <a:t>[~0:40] C1.3/C1.4 : Data Lake Parquet, Docker, healthchecks, volumes persistants, local-first.</a:t>
+            </a:r>
+          </a:p>
+        </p:txBody>
+      </p:sp>
+      <p:sp>
+        <p:nvSpPr>
+          <p:cNvPr id="4" name="Slide Number Placeholder 3"/>
+          <p:cNvSpPr>
+            <a:spLocks noGrp="1"/>
+          </p:cNvSpPr>
+          <p:nvPr>
+            <p:ph type="sldNum" idx="5" sz="quarter"/>
+          </p:nvPr>
+        </p:nvSpPr>
+        <p:spPr/>
+      </p:sp>
+    </p:spTree>
+  </p:cSld>
+  <p:clrMapOvr>
+    <a:masterClrMapping/>
+  </p:clrMapOvr>
+</p:notes>
+</file>
+
+<file path=ppt/notesSlides/notesSlide9.xml><?xml version="1.0" encoding="utf-8"?>
+<p:notes xmlns:a="http://schemas.openxmlformats.org/drawingml/2006/main" xmlns:p="http://schemas.openxmlformats.org/presentationml/2006/main" xmlns:r="http://schemas.openxmlformats.org/officeDocument/2006/relationships">
+  <p:cSld>
+    <p:spTree>
+      <p:nvGrpSpPr>
+        <p:cNvPr id="1" name=""/>
+        <p:cNvGrpSpPr/>
+        <p:nvPr/>
+      </p:nvGrpSpPr>
+      <p:grpSpPr>
+        <a:xfrm>
+          <a:off x="0" y="0"/>
+          <a:ext cx="0" cy="0"/>
+          <a:chOff x="0" y="0"/>
+          <a:chExt cx="0" cy="0"/>
+        </a:xfrm>
+      </p:grpSpPr>
+      <p:sp>
+        <p:nvSpPr>
+          <p:cNvPr id="2" name="Slide Image Placeholder 1"/>
+          <p:cNvSpPr>
+            <a:spLocks noGrp="1"/>
+          </p:cNvSpPr>
+          <p:nvPr>
+            <p:ph type="sldImg" idx="2"/>
+          </p:nvPr>
+        </p:nvSpPr>
+        <p:spPr/>
+      </p:sp>
+      <p:sp>
+        <p:nvSpPr>
+          <p:cNvPr id="3" name="Notes Placeholder 2"/>
+          <p:cNvSpPr>
+            <a:spLocks noGrp="1"/>
+          </p:cNvSpPr>
+          <p:nvPr>
+            <p:ph type="body" idx="3" sz="quarter"/>
+          </p:nvPr>
+        </p:nvSpPr>
+        <p:spPr/>
+        <p:txBody>
+          <a:bodyPr/>
+          <a:lstStyle/>
+          <a:p>
+            <a:r>
+              <a:t>[~0:50] C2.1 : API FastAPI, auth JWT + quotas par IP. Montrer /docs en demo.</a:t>
+            </a:r>
+          </a:p>
+        </p:txBody>
+      </p:sp>
+      <p:sp>
+        <p:nvSpPr>
+          <p:cNvPr id="4" name="Slide Number Placeholder 3"/>
+          <p:cNvSpPr>
+            <a:spLocks noGrp="1"/>
+          </p:cNvSpPr>
+          <p:nvPr>
+            <p:ph type="sldNum" idx="5" sz="quarter"/>
+          </p:nvPr>
+        </p:nvSpPr>
+        <p:spPr/>
+      </p:sp>
+    </p:spTree>
+  </p:cSld>
+  <p:clrMapOvr>
+    <a:masterClrMapping/>
+  </p:clrMapOvr>
+</p:notes>
 </file>
 
 <file path=ppt/slideLayouts/slideLayout1.xml><?xml version="1.0" encoding="utf-8"?>
@@ -14989,4 +16459,324 @@
   </a:objectDefaults>
   <a:extraClrSchemeLst/>
 </a:theme>
+</file>
+
+<file path=ppt/theme/theme2.xml><?xml version="1.0" encoding="utf-8"?>
+<a:theme xmlns:a="http://schemas.openxmlformats.org/drawingml/2006/main" name="Office Theme">
+  <a:themeElements>
+    <a:clrScheme name="Office">
+      <a:dk1>
+        <a:sysClr val="windowText" lastClr="000000"/>
+      </a:dk1>
+      <a:lt1>
+        <a:sysClr val="window" lastClr="FFFFFF"/>
+      </a:lt1>
+      <a:dk2>
+        <a:srgbClr val="1F497D"/>
+      </a:dk2>
+      <a:lt2>
+        <a:srgbClr val="EEECE1"/>
+      </a:lt2>
+      <a:accent1>
+        <a:srgbClr val="4F81BD"/>
+      </a:accent1>
+      <a:accent2>
+        <a:srgbClr val="C0504D"/>
+      </a:accent2>
+      <a:accent3>
+        <a:srgbClr val="9BBB59"/>
+      </a:accent3>
+      <a:accent4>
+        <a:srgbClr val="8064A2"/>
+      </a:accent4>
+      <a:accent5>
+        <a:srgbClr val="4BACC6"/>
+      </a:accent5>
+      <a:accent6>
+        <a:srgbClr val="F79646"/>
+      </a:accent6>
+      <a:hlink>
+        <a:srgbClr val="0000FF"/>
+      </a:hlink>
+      <a:folHlink>
+        <a:srgbClr val="800080"/>
+      </a:folHlink>
+    </a:clrScheme>
+    <a:fontScheme name="Office">
+      <a:majorFont>
+        <a:latin typeface="Calibri"/>
+        <a:ea typeface=""/>
+        <a:cs typeface=""/>
+        <a:font script="Jpan" typeface="ＭＳ Ｐゴシック"/>
+        <a:font script="Hang" typeface="맑은 고딕"/>
+        <a:font script="Hans" typeface="宋体"/>
+        <a:font script="Hant" typeface="新細明體"/>
+        <a:font script="Arab" typeface="Times New Roman"/>
+        <a:font script="Hebr" typeface="Times New Roman"/>
+        <a:font script="Thai" typeface="Angsana New"/>
+        <a:font script="Ethi" typeface="Nyala"/>
+        <a:font script="Beng" typeface="Vrinda"/>
+        <a:font script="Gujr" typeface="Shruti"/>
+        <a:font script="Khmr" typeface="MoolBoran"/>
+        <a:font script="Knda" typeface="Tunga"/>
+        <a:font script="Guru" typeface="Raavi"/>
+        <a:font script="Cans" typeface="Euphemia"/>
+        <a:font script="Cher" typeface="Plantagenet Cherokee"/>
+        <a:font script="Yiii" typeface="Microsoft Yi Baiti"/>
+        <a:font script="Tibt" typeface="Microsoft Himalaya"/>
+        <a:font script="Thaa" typeface="MV Boli"/>
+        <a:font script="Deva" typeface="Mangal"/>
+        <a:font script="Telu" typeface="Gautami"/>
+        <a:font script="Taml" typeface="Latha"/>
+        <a:font script="Syrc" typeface="Estrangelo Edessa"/>
+        <a:font script="Orya" typeface="Kalinga"/>
+        <a:font script="Mlym" typeface="Kartika"/>
+        <a:font script="Laoo" typeface="DokChampa"/>
+        <a:font script="Sinh" typeface="Iskoola Pota"/>
+        <a:font script="Mong" typeface="Mongolian Baiti"/>
+        <a:font script="Viet" typeface="Times New Roman"/>
+        <a:font script="Uigh" typeface="Microsoft Uighur"/>
+        <a:font script="Geor" typeface="Sylfaen"/>
+      </a:majorFont>
+      <a:minorFont>
+        <a:latin typeface="Calibri"/>
+        <a:ea typeface=""/>
+        <a:cs typeface=""/>
+        <a:font script="Jpan" typeface="ＭＳ Ｐゴシック"/>
+        <a:font script="Hang" typeface="맑은 고딕"/>
+        <a:font script="Hans" typeface="宋体"/>
+        <a:font script="Hant" typeface="新細明體"/>
+        <a:font script="Arab" typeface="Arial"/>
+        <a:font script="Hebr" typeface="Arial"/>
+        <a:font script="Thai" typeface="Cordia New"/>
+        <a:font script="Ethi" typeface="Nyala"/>
+        <a:font script="Beng" typeface="Vrinda"/>
+        <a:font script="Gujr" typeface="Shruti"/>
+        <a:font script="Khmr" typeface="DaunPenh"/>
+        <a:font script="Knda" typeface="Tunga"/>
+        <a:font script="Guru" typeface="Raavi"/>
+        <a:font script="Cans" typeface="Euphemia"/>
+        <a:font script="Cher" typeface="Plantagenet Cherokee"/>
+        <a:font script="Yiii" typeface="Microsoft Yi Baiti"/>
+        <a:font script="Tibt" typeface="Microsoft Himalaya"/>
+        <a:font script="Thaa" typeface="MV Boli"/>
+        <a:font script="Deva" typeface="Mangal"/>
+        <a:font script="Telu" typeface="Gautami"/>
+        <a:font script="Taml" typeface="Latha"/>
+        <a:font script="Syrc" typeface="Estrangelo Edessa"/>
+        <a:font script="Orya" typeface="Kalinga"/>
+        <a:font script="Mlym" typeface="Kartika"/>
+        <a:font script="Laoo" typeface="DokChampa"/>
+        <a:font script="Sinh" typeface="Iskoola Pota"/>
+        <a:font script="Mong" typeface="Mongolian Baiti"/>
+        <a:font script="Viet" typeface="Arial"/>
+        <a:font script="Uigh" typeface="Microsoft Uighur"/>
+        <a:font script="Geor" typeface="Sylfaen"/>
+      </a:minorFont>
+    </a:fontScheme>
+    <a:fmtScheme name="Office">
+      <a:fillStyleLst>
+        <a:solidFill>
+          <a:schemeClr val="phClr"/>
+        </a:solidFill>
+        <a:gradFill rotWithShape="1">
+          <a:gsLst>
+            <a:gs pos="0">
+              <a:schemeClr val="phClr">
+                <a:tint val="50000"/>
+                <a:satMod val="300000"/>
+              </a:schemeClr>
+            </a:gs>
+            <a:gs pos="35000">
+              <a:schemeClr val="phClr">
+                <a:tint val="37000"/>
+                <a:satMod val="300000"/>
+              </a:schemeClr>
+            </a:gs>
+            <a:gs pos="100000">
+              <a:schemeClr val="phClr">
+                <a:tint val="15000"/>
+                <a:satMod val="350000"/>
+              </a:schemeClr>
+            </a:gs>
+          </a:gsLst>
+          <a:lin ang="16200000" scaled="1"/>
+        </a:gradFill>
+        <a:gradFill rotWithShape="1">
+          <a:gsLst>
+            <a:gs pos="0">
+              <a:schemeClr val="phClr">
+                <a:tint val="100000"/>
+                <a:shade val="100000"/>
+                <a:satMod val="130000"/>
+              </a:schemeClr>
+            </a:gs>
+            <a:gs pos="100000">
+              <a:schemeClr val="phClr">
+                <a:tint val="50000"/>
+                <a:shade val="100000"/>
+                <a:satMod val="350000"/>
+              </a:schemeClr>
+            </a:gs>
+          </a:gsLst>
+          <a:lin ang="16200000" scaled="0"/>
+        </a:gradFill>
+      </a:fillStyleLst>
+      <a:lnStyleLst>
+        <a:ln w="9525" cap="flat" cmpd="sng" algn="ctr">
+          <a:solidFill>
+            <a:schemeClr val="phClr">
+              <a:shade val="95000"/>
+              <a:satMod val="105000"/>
+            </a:schemeClr>
+          </a:solidFill>
+          <a:prstDash val="solid"/>
+        </a:ln>
+        <a:ln w="25400" cap="flat" cmpd="sng" algn="ctr">
+          <a:solidFill>
+            <a:schemeClr val="phClr"/>
+          </a:solidFill>
+          <a:prstDash val="solid"/>
+        </a:ln>
+        <a:ln w="38100" cap="flat" cmpd="sng" algn="ctr">
+          <a:solidFill>
+            <a:schemeClr val="phClr"/>
+          </a:solidFill>
+          <a:prstDash val="solid"/>
+        </a:ln>
+      </a:lnStyleLst>
+      <a:effectStyleLst>
+        <a:effectStyle>
+          <a:effectLst>
+            <a:outerShdw blurRad="40000" dist="20000" dir="5400000" rotWithShape="0">
+              <a:srgbClr val="000000">
+                <a:alpha val="38000"/>
+              </a:srgbClr>
+            </a:outerShdw>
+          </a:effectLst>
+        </a:effectStyle>
+        <a:effectStyle>
+          <a:effectLst>
+            <a:outerShdw blurRad="40000" dist="23000" dir="5400000" rotWithShape="0">
+              <a:srgbClr val="000000">
+                <a:alpha val="35000"/>
+              </a:srgbClr>
+            </a:outerShdw>
+          </a:effectLst>
+        </a:effectStyle>
+        <a:effectStyle>
+          <a:effectLst>
+            <a:outerShdw blurRad="40000" dist="23000" dir="5400000" rotWithShape="0">
+              <a:srgbClr val="000000">
+                <a:alpha val="35000"/>
+              </a:srgbClr>
+            </a:outerShdw>
+          </a:effectLst>
+          <a:scene3d>
+            <a:camera prst="orthographicFront">
+              <a:rot lat="0" lon="0" rev="0"/>
+            </a:camera>
+            <a:lightRig rig="threePt" dir="t">
+              <a:rot lat="0" lon="0" rev="1200000"/>
+            </a:lightRig>
+          </a:scene3d>
+          <a:sp3d>
+            <a:bevelT w="63500" h="25400"/>
+          </a:sp3d>
+        </a:effectStyle>
+      </a:effectStyleLst>
+      <a:bgFillStyleLst>
+        <a:solidFill>
+          <a:schemeClr val="phClr"/>
+        </a:solidFill>
+        <a:gradFill rotWithShape="1">
+          <a:gsLst>
+            <a:gs pos="0">
+              <a:schemeClr val="phClr">
+                <a:tint val="40000"/>
+                <a:satMod val="350000"/>
+              </a:schemeClr>
+            </a:gs>
+            <a:gs pos="40000">
+              <a:schemeClr val="phClr">
+                <a:tint val="45000"/>
+                <a:shade val="99000"/>
+                <a:satMod val="350000"/>
+              </a:schemeClr>
+            </a:gs>
+            <a:gs pos="100000">
+              <a:schemeClr val="phClr">
+                <a:shade val="20000"/>
+                <a:satMod val="255000"/>
+              </a:schemeClr>
+            </a:gs>
+          </a:gsLst>
+          <a:path path="circle">
+            <a:fillToRect l="50000" t="-80000" r="50000" b="180000"/>
+          </a:path>
+        </a:gradFill>
+        <a:gradFill rotWithShape="1">
+          <a:gsLst>
+            <a:gs pos="0">
+              <a:schemeClr val="phClr">
+                <a:tint val="80000"/>
+                <a:satMod val="300000"/>
+              </a:schemeClr>
+            </a:gs>
+            <a:gs pos="100000">
+              <a:schemeClr val="phClr">
+                <a:shade val="30000"/>
+                <a:satMod val="200000"/>
+              </a:schemeClr>
+            </a:gs>
+          </a:gsLst>
+          <a:path path="circle">
+            <a:fillToRect l="50000" t="50000" r="50000" b="50000"/>
+          </a:path>
+        </a:gradFill>
+      </a:bgFillStyleLst>
+    </a:fmtScheme>
+  </a:themeElements>
+  <a:objectDefaults>
+    <a:spDef>
+      <a:spPr/>
+      <a:bodyPr/>
+      <a:lstStyle/>
+      <a:style>
+        <a:lnRef idx="1">
+          <a:schemeClr val="accent1"/>
+        </a:lnRef>
+        <a:fillRef idx="3">
+          <a:schemeClr val="accent1"/>
+        </a:fillRef>
+        <a:effectRef idx="2">
+          <a:schemeClr val="accent1"/>
+        </a:effectRef>
+        <a:fontRef idx="minor">
+          <a:schemeClr val="lt1"/>
+        </a:fontRef>
+      </a:style>
+    </a:spDef>
+    <a:lnDef>
+      <a:spPr/>
+      <a:bodyPr/>
+      <a:lstStyle/>
+      <a:style>
+        <a:lnRef idx="2">
+          <a:schemeClr val="accent1"/>
+        </a:lnRef>
+        <a:fillRef idx="0">
+          <a:schemeClr val="accent1"/>
+        </a:fillRef>
+        <a:effectRef idx="1">
+          <a:schemeClr val="accent1"/>
+        </a:effectRef>
+        <a:fontRef idx="minor">
+          <a:schemeClr val="tx1"/>
+        </a:fontRef>
+      </a:style>
+    </a:lnDef>
+  </a:objectDefaults>
+  <a:extraClrSchemeLst/>
+</a:theme>
 </file>
</xml_diff>

<commit_message>
refactor: migrate district_rows to 4-family model, update deliverables
</commit_message>
<xml_diff>
--- a/soutenance.pptx
+++ b/soutenance.pptx
@@ -10332,7 +10332,7 @@
                 </a:solidFill>
                 <a:latin typeface="Arial"/>
               </a:rPr>
-              <a:t>Architecture d'ensemble (médaillon)</a:t>
+              <a:t>Architecture médaillon (Bronze/Silver/Gold)</a:t>
             </a:r>
           </a:p>
           <a:p>
@@ -10369,7 +10369,7 @@
                 </a:solidFill>
                 <a:latin typeface="Arial"/>
               </a:rPr>
-              <a:t>Sources Open Data &amp; géocodage</a:t>
+              <a:t>83 sources · 4 familles · OSM Overpass</a:t>
             </a:r>
           </a:p>
           <a:p>
@@ -10725,7 +10725,7 @@
                 </a:solidFill>
                 <a:latin typeface="Arial"/>
               </a:rPr>
-              <a:t>Conformité grille &amp; conclusion</a:t>
+              <a:t>Conformité grille RNCP &amp; conclusion</a:t>
             </a:r>
           </a:p>
         </p:txBody>
@@ -11386,7 +11386,7 @@
                 </a:solidFill>
                 <a:latin typeface="Arial"/>
               </a:rPr>
-              <a:t>24</a:t>
+              <a:t>83</a:t>
             </a:r>
           </a:p>
           <a:p>
@@ -11424,7 +11424,7 @@
                 </a:solidFill>
                 <a:latin typeface="Arial"/>
               </a:rPr>
-              <a:t>8</a:t>
+              <a:t>4</a:t>
             </a:r>
           </a:p>
           <a:p>
@@ -11500,7 +11500,7 @@
                 </a:solidFill>
                 <a:latin typeface="Arial"/>
               </a:rPr>
-              <a:t>5</a:t>
+              <a:t>118</a:t>
             </a:r>
           </a:p>
           <a:p>
@@ -11519,7 +11519,7 @@
                 </a:solidFill>
                 <a:latin typeface="Arial"/>
               </a:rPr>
-              <a:t>niveaux de granularité</a:t>
+              <a:t>tests pytest verts</a:t>
             </a:r>
           </a:p>
         </p:txBody>
@@ -12785,7 +12785,7 @@
                 </a:solidFill>
                 <a:latin typeface="Arial"/>
               </a:rPr>
-              <a:t>24 sources, 8 familles : </a:t>
+              <a:t>83 sources, 4 familles : </a:t>
             </a:r>
             <a:r>
               <a:rPr sz="1400" b="0">
@@ -12794,7 +12794,7 @@
                 </a:solidFill>
                 <a:latin typeface="Arial"/>
               </a:rPr>
-              <a:t>mobilité, éducation, logement, culture, santé, espaces verts, services publics, pression urbaine.</a:t>
+              <a:t>mobilité (17), vie quotidienne (42), environnement (12), logement &amp; urbanisme (12). 30 sources OSM Overpass.</a:t>
             </a:r>
           </a:p>
           <a:p>
@@ -13065,7 +13065,7 @@
                 </a:solidFill>
                 <a:latin typeface="Arial"/>
               </a:rPr>
-              <a:t>   7</a:t>
+              <a:t>   17</a:t>
             </a:r>
           </a:p>
           <a:p>
@@ -13084,7 +13084,7 @@
                 </a:solidFill>
                 <a:latin typeface="Arial"/>
               </a:rPr>
-              <a:t>Logement</a:t>
+              <a:t>Vie quotidienne</a:t>
             </a:r>
             <a:r>
               <a:rPr sz="1300" b="0">
@@ -13093,7 +13093,7 @@
                 </a:solidFill>
                 <a:latin typeface="Arial"/>
               </a:rPr>
-              <a:t>   3</a:t>
+              <a:t>   42</a:t>
             </a:r>
           </a:p>
           <a:p>
@@ -13112,7 +13112,7 @@
                 </a:solidFill>
                 <a:latin typeface="Arial"/>
               </a:rPr>
-              <a:t>Éducation</a:t>
+              <a:t>Environnement</a:t>
             </a:r>
             <a:r>
               <a:rPr sz="1300" b="0">
@@ -13121,7 +13121,7 @@
                 </a:solidFill>
                 <a:latin typeface="Arial"/>
               </a:rPr>
-              <a:t>   3</a:t>
+              <a:t>   12</a:t>
             </a:r>
           </a:p>
           <a:p>
@@ -13140,7 +13140,7 @@
                 </a:solidFill>
                 <a:latin typeface="Arial"/>
               </a:rPr>
-              <a:t>Espaces verts</a:t>
+              <a:t>Logement &amp; urbanisme</a:t>
             </a:r>
             <a:r>
               <a:rPr sz="1300" b="0">
@@ -13149,7 +13149,7 @@
                 </a:solidFill>
                 <a:latin typeface="Arial"/>
               </a:rPr>
-              <a:t>   3</a:t>
+              <a:t>   12</a:t>
             </a:r>
           </a:p>
           <a:p>
@@ -13162,106 +13162,22 @@
               </a:spcAft>
             </a:pPr>
             <a:r>
-              <a:rPr sz="1300" b="1">
-                <a:solidFill>
-                  <a:srgbClr val="161616"/>
-                </a:solidFill>
-                <a:latin typeface="Arial"/>
-              </a:rPr>
-              <a:t>Services publics</a:t>
-            </a:r>
-            <a:r>
               <a:rPr sz="1300" b="0">
                 <a:solidFill>
-                  <a:srgbClr val="3A3A3A"/>
-                </a:solidFill>
-                <a:latin typeface="Arial"/>
-              </a:rPr>
-              <a:t>   3</a:t>
-            </a:r>
-          </a:p>
-          <a:p>
-            <a:pPr algn="l">
-              <a:spcBef>
-                <a:spcPts val="0"/>
-              </a:spcBef>
-              <a:spcAft>
-                <a:spcPts val="600"/>
-              </a:spcAft>
-            </a:pPr>
-            <a:r>
-              <a:rPr sz="1300" b="1">
-                <a:solidFill>
-                  <a:srgbClr val="161616"/>
-                </a:solidFill>
-                <a:latin typeface="Arial"/>
-              </a:rPr>
-              <a:t>Culture</a:t>
+                  <a:srgbClr val="666666"/>
+                </a:solidFill>
+                <a:latin typeface="Arial"/>
+              </a:rPr>
+              <a:t>dont OSM Overpass</a:t>
             </a:r>
             <a:r>
               <a:rPr sz="1300" b="0">
                 <a:solidFill>
-                  <a:srgbClr val="3A3A3A"/>
-                </a:solidFill>
-                <a:latin typeface="Arial"/>
-              </a:rPr>
-              <a:t>   2</a:t>
-            </a:r>
-          </a:p>
-          <a:p>
-            <a:pPr algn="l">
-              <a:spcBef>
-                <a:spcPts val="0"/>
-              </a:spcBef>
-              <a:spcAft>
-                <a:spcPts val="600"/>
-              </a:spcAft>
-            </a:pPr>
-            <a:r>
-              <a:rPr sz="1300" b="1">
-                <a:solidFill>
-                  <a:srgbClr val="161616"/>
-                </a:solidFill>
-                <a:latin typeface="Arial"/>
-              </a:rPr>
-              <a:t>Santé</a:t>
-            </a:r>
-            <a:r>
-              <a:rPr sz="1300" b="0">
-                <a:solidFill>
-                  <a:srgbClr val="3A3A3A"/>
-                </a:solidFill>
-                <a:latin typeface="Arial"/>
-              </a:rPr>
-              <a:t>   2</a:t>
-            </a:r>
-          </a:p>
-          <a:p>
-            <a:pPr algn="l">
-              <a:spcBef>
-                <a:spcPts val="0"/>
-              </a:spcBef>
-              <a:spcAft>
-                <a:spcPts val="600"/>
-              </a:spcAft>
-            </a:pPr>
-            <a:r>
-              <a:rPr sz="1300" b="1">
-                <a:solidFill>
-                  <a:srgbClr val="161616"/>
-                </a:solidFill>
-                <a:latin typeface="Arial"/>
-              </a:rPr>
-              <a:t>Pression urbaine</a:t>
-            </a:r>
-            <a:r>
-              <a:rPr sz="1300" b="0">
-                <a:solidFill>
-                  <a:srgbClr val="3A3A3A"/>
-                </a:solidFill>
-                <a:latin typeface="Arial"/>
-              </a:rPr>
-              <a:t>   1</a:t>
+                  <a:srgbClr val="666666"/>
+                </a:solidFill>
+                <a:latin typeface="Arial"/>
+              </a:rPr>
+              <a:t>   30</a:t>
             </a:r>
           </a:p>
         </p:txBody>

</xml_diff>